<commit_message>
Fix deployment section: Cloudflare Tunnel, no Docker
</commit_message>
<xml_diff>
--- a/AI_Resume_Optimizer_Presentation.pptx
+++ b/AI_Resume_Optimizer_Presentation.pptx
@@ -3912,7 +3912,7 @@
               </a:defRPr>
             </a:pPr>
             <a:r>
-              <a:t>Deployment Guide</a:t>
+              <a:t>Deployment (Cloudflare Tunnel)</a:t>
             </a:r>
           </a:p>
         </p:txBody>
@@ -3948,7 +3948,7 @@
               </a:defRPr>
             </a:pPr>
             <a:r>
-              <a:t>Run it anywhere — local, cloud, or managed</a:t>
+              <a:t>Local deployment -- no Docker, no ngrok, no cloud subs</a:t>
             </a:r>
           </a:p>
         </p:txBody>
@@ -4005,7 +4005,7 @@
         <p:spPr>
           <a:xfrm>
             <a:off x="457200" y="1371600"/>
-            <a:ext cx="3657600" cy="2286000"/>
+            <a:ext cx="11247120" cy="1645920"/>
           </a:xfrm>
           <a:prstGeom prst="roundRect">
             <a:avLst/>
@@ -4049,21 +4049,57 @@
         <p:spPr>
           <a:xfrm>
             <a:off x="640080" y="1463040"/>
-            <a:ext cx="3291840" cy="365760"/>
-          </a:xfrm>
-          <a:prstGeom prst="rect">
-            <a:avLst/>
-          </a:prstGeom>
-          <a:noFill/>
-        </p:spPr>
-        <p:txBody>
-          <a:bodyPr wrap="square">
-            <a:spAutoFit/>
-          </a:bodyPr>
-          <a:lstStyle/>
-          <a:p>
-            <a:pPr algn="l">
-              <a:defRPr sz="1800" b="1">
+            <a:ext cx="5029200" cy="365760"/>
+          </a:xfrm>
+          <a:prstGeom prst="rect">
+            <a:avLst/>
+          </a:prstGeom>
+          <a:noFill/>
+        </p:spPr>
+        <p:txBody>
+          <a:bodyPr wrap="square">
+            <a:spAutoFit/>
+          </a:bodyPr>
+          <a:lstStyle/>
+          <a:p>
+            <a:pPr algn="l">
+              <a:defRPr sz="2000" b="1">
+                <a:solidFill>
+                  <a:srgbClr val="FFFFFF"/>
+                </a:solidFill>
+                <a:latin typeface="Calibri"/>
+              </a:defRPr>
+            </a:pPr>
+            <a:r>
+              <a:t>Why Cloudflare Tunnel?</a:t>
+            </a:r>
+          </a:p>
+        </p:txBody>
+      </p:sp>
+      <p:sp>
+        <p:nvSpPr>
+          <p:cNvPr id="9" name="TextBox 8"/>
+          <p:cNvSpPr txBox="1"/>
+          <p:nvPr/>
+        </p:nvSpPr>
+        <p:spPr>
+          <a:xfrm>
+            <a:off x="640080" y="1920240"/>
+            <a:ext cx="2560320" cy="274320"/>
+          </a:xfrm>
+          <a:prstGeom prst="rect">
+            <a:avLst/>
+          </a:prstGeom>
+          <a:noFill/>
+        </p:spPr>
+        <p:txBody>
+          <a:bodyPr wrap="square">
+            <a:spAutoFit/>
+          </a:bodyPr>
+          <a:lstStyle/>
+          <a:p>
+            <a:pPr algn="l">
+              <a:defRPr sz="1400" b="1">
                 <a:solidFill>
                   <a:srgbClr val="A78BFA"/>
                 </a:solidFill>
@@ -4071,21 +4107,21 @@
               </a:defRPr>
             </a:pPr>
             <a:r>
-              <a:t>Local Docker</a:t>
-            </a:r>
-          </a:p>
-        </p:txBody>
-      </p:sp>
-      <p:sp>
-        <p:nvSpPr>
-          <p:cNvPr id="9" name="TextBox 8"/>
-          <p:cNvSpPr txBox="1"/>
-          <p:nvPr/>
-        </p:nvSpPr>
-        <p:spPr>
-          <a:xfrm>
-            <a:off x="640080" y="2011680"/>
-            <a:ext cx="3291840" cy="731520"/>
+              <a:t>Free HTTPS</a:t>
+            </a:r>
+          </a:p>
+        </p:txBody>
+      </p:sp>
+      <p:sp>
+        <p:nvSpPr>
+          <p:cNvPr id="10" name="TextBox 9"/>
+          <p:cNvSpPr txBox="1"/>
+          <p:nvPr/>
+        </p:nvSpPr>
+        <p:spPr>
+          <a:xfrm>
+            <a:off x="640080" y="2194560"/>
+            <a:ext cx="2560320" cy="274320"/>
           </a:xfrm>
           <a:prstGeom prst="rect">
             <a:avLst/>
@@ -4101,27 +4137,63 @@
             <a:pPr algn="l">
               <a:defRPr sz="1200" b="0">
                 <a:solidFill>
-                  <a:srgbClr val="FBBF24"/>
-                </a:solidFill>
-                <a:latin typeface="Calibri"/>
-              </a:defRPr>
-            </a:pPr>
-            <a:r>
-              <a:t>docker run -it --rm -p 5678:5678 docker.n8n.io/n8nio/n8n</a:t>
-            </a:r>
-          </a:p>
-        </p:txBody>
-      </p:sp>
-      <p:sp>
-        <p:nvSpPr>
-          <p:cNvPr id="10" name="TextBox 9"/>
-          <p:cNvSpPr txBox="1"/>
-          <p:nvPr/>
-        </p:nvSpPr>
-        <p:spPr>
-          <a:xfrm>
-            <a:off x="640080" y="2926080"/>
-            <a:ext cx="3291840" cy="365760"/>
+                  <a:srgbClr val="E0E0E0"/>
+                </a:solidFill>
+                <a:latin typeface="Calibri"/>
+              </a:defRPr>
+            </a:pPr>
+            <a:r>
+              <a:t>No URL changes drama</a:t>
+            </a:r>
+          </a:p>
+        </p:txBody>
+      </p:sp>
+      <p:sp>
+        <p:nvSpPr>
+          <p:cNvPr id="11" name="TextBox 10"/>
+          <p:cNvSpPr txBox="1"/>
+          <p:nvPr/>
+        </p:nvSpPr>
+        <p:spPr>
+          <a:xfrm>
+            <a:off x="3383280" y="1920240"/>
+            <a:ext cx="2560320" cy="274320"/>
+          </a:xfrm>
+          <a:prstGeom prst="rect">
+            <a:avLst/>
+          </a:prstGeom>
+          <a:noFill/>
+        </p:spPr>
+        <p:txBody>
+          <a:bodyPr wrap="square">
+            <a:spAutoFit/>
+          </a:bodyPr>
+          <a:lstStyle/>
+          <a:p>
+            <a:pPr algn="l">
+              <a:defRPr sz="1400" b="1">
+                <a:solidFill>
+                  <a:srgbClr val="A78BFA"/>
+                </a:solidFill>
+                <a:latin typeface="Calibri"/>
+              </a:defRPr>
+            </a:pPr>
+            <a:r>
+              <a:t>Stable</a:t>
+            </a:r>
+          </a:p>
+        </p:txBody>
+      </p:sp>
+      <p:sp>
+        <p:nvSpPr>
+          <p:cNvPr id="12" name="TextBox 11"/>
+          <p:cNvSpPr txBox="1"/>
+          <p:nvPr/>
+        </p:nvSpPr>
+        <p:spPr>
+          <a:xfrm>
+            <a:off x="3383280" y="2194560"/>
+            <a:ext cx="2560320" cy="274320"/>
           </a:xfrm>
           <a:prstGeom prst="rect">
             <a:avLst/>
@@ -4137,27 +4209,171 @@
             <a:pPr algn="l">
               <a:defRPr sz="1200" b="0">
                 <a:solidFill>
-                  <a:srgbClr val="34D399"/>
-                </a:solidFill>
-                <a:latin typeface="Calibri"/>
-              </a:defRPr>
-            </a:pPr>
-            <a:r>
-              <a:t>Self-hosted, full control, free</a:t>
-            </a:r>
-          </a:p>
-        </p:txBody>
-      </p:sp>
-      <p:sp>
-        <p:nvSpPr>
-          <p:cNvPr id="11" name="Rounded Rectangle 10"/>
+                  <a:srgbClr val="E0E0E0"/>
+                </a:solidFill>
+                <a:latin typeface="Calibri"/>
+              </a:defRPr>
+            </a:pPr>
+            <a:r>
+              <a:t>Long-running tunnel for bots</a:t>
+            </a:r>
+          </a:p>
+        </p:txBody>
+      </p:sp>
+      <p:sp>
+        <p:nvSpPr>
+          <p:cNvPr id="13" name="TextBox 12"/>
+          <p:cNvSpPr txBox="1"/>
+          <p:nvPr/>
+        </p:nvSpPr>
+        <p:spPr>
+          <a:xfrm>
+            <a:off x="6126480" y="1920240"/>
+            <a:ext cx="2560320" cy="274320"/>
+          </a:xfrm>
+          <a:prstGeom prst="rect">
+            <a:avLst/>
+          </a:prstGeom>
+          <a:noFill/>
+        </p:spPr>
+        <p:txBody>
+          <a:bodyPr wrap="square">
+            <a:spAutoFit/>
+          </a:bodyPr>
+          <a:lstStyle/>
+          <a:p>
+            <a:pPr algn="l">
+              <a:defRPr sz="1400" b="1">
+                <a:solidFill>
+                  <a:srgbClr val="A78BFA"/>
+                </a:solidFill>
+                <a:latin typeface="Calibri"/>
+              </a:defRPr>
+            </a:pPr>
+            <a:r>
+              <a:t>Auto</a:t>
+            </a:r>
+          </a:p>
+        </p:txBody>
+      </p:sp>
+      <p:sp>
+        <p:nvSpPr>
+          <p:cNvPr id="14" name="TextBox 13"/>
+          <p:cNvSpPr txBox="1"/>
+          <p:nvPr/>
+        </p:nvSpPr>
+        <p:spPr>
+          <a:xfrm>
+            <a:off x="6126480" y="2194560"/>
+            <a:ext cx="2560320" cy="274320"/>
+          </a:xfrm>
+          <a:prstGeom prst="rect">
+            <a:avLst/>
+          </a:prstGeom>
+          <a:noFill/>
+        </p:spPr>
+        <p:txBody>
+          <a:bodyPr wrap="square">
+            <a:spAutoFit/>
+          </a:bodyPr>
+          <a:lstStyle/>
+          <a:p>
+            <a:pPr algn="l">
+              <a:defRPr sz="1200" b="0">
+                <a:solidFill>
+                  <a:srgbClr val="E0E0E0"/>
+                </a:solidFill>
+                <a:latin typeface="Calibri"/>
+              </a:defRPr>
+            </a:pPr>
+            <a:r>
+              <a:t>Script reads URL + sets env vars</a:t>
+            </a:r>
+          </a:p>
+        </p:txBody>
+      </p:sp>
+      <p:sp>
+        <p:nvSpPr>
+          <p:cNvPr id="15" name="TextBox 14"/>
+          <p:cNvSpPr txBox="1"/>
+          <p:nvPr/>
+        </p:nvSpPr>
+        <p:spPr>
+          <a:xfrm>
+            <a:off x="8869680" y="1920240"/>
+            <a:ext cx="2560320" cy="274320"/>
+          </a:xfrm>
+          <a:prstGeom prst="rect">
+            <a:avLst/>
+          </a:prstGeom>
+          <a:noFill/>
+        </p:spPr>
+        <p:txBody>
+          <a:bodyPr wrap="square">
+            <a:spAutoFit/>
+          </a:bodyPr>
+          <a:lstStyle/>
+          <a:p>
+            <a:pPr algn="l">
+              <a:defRPr sz="1400" b="1">
+                <a:solidFill>
+                  <a:srgbClr val="A78BFA"/>
+                </a:solidFill>
+                <a:latin typeface="Calibri"/>
+              </a:defRPr>
+            </a:pPr>
+            <a:r>
+              <a:t>Set &amp; Forget</a:t>
+            </a:r>
+          </a:p>
+        </p:txBody>
+      </p:sp>
+      <p:sp>
+        <p:nvSpPr>
+          <p:cNvPr id="16" name="TextBox 15"/>
+          <p:cNvSpPr txBox="1"/>
+          <p:nvPr/>
+        </p:nvSpPr>
+        <p:spPr>
+          <a:xfrm>
+            <a:off x="8869680" y="2194560"/>
+            <a:ext cx="2560320" cy="274320"/>
+          </a:xfrm>
+          <a:prstGeom prst="rect">
+            <a:avLst/>
+          </a:prstGeom>
+          <a:noFill/>
+        </p:spPr>
+        <p:txBody>
+          <a:bodyPr wrap="square">
+            <a:spAutoFit/>
+          </a:bodyPr>
+          <a:lstStyle/>
+          <a:p>
+            <a:pPr algn="l">
+              <a:defRPr sz="1200" b="0">
+                <a:solidFill>
+                  <a:srgbClr val="E0E0E0"/>
+                </a:solidFill>
+                <a:latin typeface="Calibri"/>
+              </a:defRPr>
+            </a:pPr>
+            <a:r>
+              <a:t>Less overhead than ngrok</a:t>
+            </a:r>
+          </a:p>
+        </p:txBody>
+      </p:sp>
+      <p:sp>
+        <p:nvSpPr>
+          <p:cNvPr id="17" name="Rounded Rectangle 16"/>
           <p:cNvSpPr/>
           <p:nvPr/>
         </p:nvSpPr>
         <p:spPr>
           <a:xfrm>
-            <a:off x="4389120" y="1371600"/>
-            <a:ext cx="3657600" cy="2286000"/>
+            <a:off x="457200" y="3200400"/>
+            <a:ext cx="11247120" cy="1645920"/>
           </a:xfrm>
           <a:prstGeom prst="roundRect">
             <a:avLst/>
@@ -4194,122 +4410,194 @@
       </p:sp>
       <p:sp>
         <p:nvSpPr>
-          <p:cNvPr id="12" name="TextBox 11"/>
-          <p:cNvSpPr txBox="1"/>
-          <p:nvPr/>
-        </p:nvSpPr>
-        <p:spPr>
-          <a:xfrm>
-            <a:off x="4572000" y="1463040"/>
-            <a:ext cx="3291840" cy="365760"/>
-          </a:xfrm>
-          <a:prstGeom prst="rect">
-            <a:avLst/>
-          </a:prstGeom>
-          <a:noFill/>
-        </p:spPr>
-        <p:txBody>
-          <a:bodyPr wrap="square">
-            <a:spAutoFit/>
-          </a:bodyPr>
-          <a:lstStyle/>
-          <a:p>
-            <a:pPr algn="l">
-              <a:defRPr sz="1800" b="1">
-                <a:solidFill>
-                  <a:srgbClr val="A78BFA"/>
-                </a:solidFill>
-                <a:latin typeface="Calibri"/>
-              </a:defRPr>
-            </a:pPr>
-            <a:r>
-              <a:t>n8n.cloud</a:t>
-            </a:r>
-          </a:p>
-        </p:txBody>
-      </p:sp>
-      <p:sp>
-        <p:nvSpPr>
-          <p:cNvPr id="13" name="TextBox 12"/>
-          <p:cNvSpPr txBox="1"/>
-          <p:nvPr/>
-        </p:nvSpPr>
-        <p:spPr>
-          <a:xfrm>
-            <a:off x="4572000" y="2011680"/>
-            <a:ext cx="3291840" cy="731520"/>
-          </a:xfrm>
-          <a:prstGeom prst="rect">
-            <a:avLst/>
-          </a:prstGeom>
-          <a:noFill/>
-        </p:spPr>
-        <p:txBody>
-          <a:bodyPr wrap="square">
-            <a:spAutoFit/>
-          </a:bodyPr>
-          <a:lstStyle/>
-          <a:p>
-            <a:pPr algn="l">
-              <a:defRPr sz="1200" b="0">
-                <a:solidFill>
-                  <a:srgbClr val="FBBF24"/>
-                </a:solidFill>
-                <a:latin typeface="Calibri"/>
-              </a:defRPr>
-            </a:pPr>
-            <a:r>
-              <a:t>Managed SaaS at n8n.cloud</a:t>
-            </a:r>
-          </a:p>
-        </p:txBody>
-      </p:sp>
-      <p:sp>
-        <p:nvSpPr>
-          <p:cNvPr id="14" name="TextBox 13"/>
-          <p:cNvSpPr txBox="1"/>
-          <p:nvPr/>
-        </p:nvSpPr>
-        <p:spPr>
-          <a:xfrm>
-            <a:off x="4572000" y="2926080"/>
-            <a:ext cx="3291840" cy="365760"/>
-          </a:xfrm>
-          <a:prstGeom prst="rect">
-            <a:avLst/>
-          </a:prstGeom>
-          <a:noFill/>
-        </p:spPr>
-        <p:txBody>
-          <a:bodyPr wrap="square">
-            <a:spAutoFit/>
-          </a:bodyPr>
-          <a:lstStyle/>
-          <a:p>
-            <a:pPr algn="l">
-              <a:defRPr sz="1200" b="0">
-                <a:solidFill>
-                  <a:srgbClr val="34D399"/>
-                </a:solidFill>
-                <a:latin typeface="Calibri"/>
-              </a:defRPr>
-            </a:pPr>
-            <a:r>
-              <a:t>Zero maintenance, free tier available</a:t>
-            </a:r>
-          </a:p>
-        </p:txBody>
-      </p:sp>
-      <p:sp>
-        <p:nvSpPr>
-          <p:cNvPr id="15" name="Rounded Rectangle 14"/>
+          <p:cNvPr id="18" name="TextBox 17"/>
+          <p:cNvSpPr txBox="1"/>
+          <p:nvPr/>
+        </p:nvSpPr>
+        <p:spPr>
+          <a:xfrm>
+            <a:off x="640080" y="3291840"/>
+            <a:ext cx="5029200" cy="365760"/>
+          </a:xfrm>
+          <a:prstGeom prst="rect">
+            <a:avLst/>
+          </a:prstGeom>
+          <a:noFill/>
+        </p:spPr>
+        <p:txBody>
+          <a:bodyPr wrap="square">
+            <a:spAutoFit/>
+          </a:bodyPr>
+          <a:lstStyle/>
+          <a:p>
+            <a:pPr algn="l">
+              <a:defRPr sz="2000" b="1">
+                <a:solidFill>
+                  <a:srgbClr val="FFFFFF"/>
+                </a:solidFill>
+                <a:latin typeface="Calibri"/>
+              </a:defRPr>
+            </a:pPr>
+            <a:r>
+              <a:t>How to Deploy</a:t>
+            </a:r>
+          </a:p>
+        </p:txBody>
+      </p:sp>
+      <p:sp>
+        <p:nvSpPr>
+          <p:cNvPr id="19" name="TextBox 18"/>
+          <p:cNvSpPr txBox="1"/>
+          <p:nvPr/>
+        </p:nvSpPr>
+        <p:spPr>
+          <a:xfrm>
+            <a:off x="640080" y="3749039"/>
+            <a:ext cx="10058400" cy="320040"/>
+          </a:xfrm>
+          <a:prstGeom prst="rect">
+            <a:avLst/>
+          </a:prstGeom>
+          <a:noFill/>
+        </p:spPr>
+        <p:txBody>
+          <a:bodyPr wrap="square">
+            <a:spAutoFit/>
+          </a:bodyPr>
+          <a:lstStyle/>
+          <a:p>
+            <a:pPr algn="l">
+              <a:defRPr sz="1400" b="0">
+                <a:solidFill>
+                  <a:srgbClr val="E0E0E0"/>
+                </a:solidFill>
+                <a:latin typeface="Calibri"/>
+              </a:defRPr>
+            </a:pPr>
+            <a:r>
+              <a:t>1. Install cloudflared from Cloudflare's download page</a:t>
+            </a:r>
+          </a:p>
+        </p:txBody>
+      </p:sp>
+      <p:sp>
+        <p:nvSpPr>
+          <p:cNvPr id="20" name="TextBox 19"/>
+          <p:cNvSpPr txBox="1"/>
+          <p:nvPr/>
+        </p:nvSpPr>
+        <p:spPr>
+          <a:xfrm>
+            <a:off x="640080" y="4114800"/>
+            <a:ext cx="10058400" cy="320040"/>
+          </a:xfrm>
+          <a:prstGeom prst="rect">
+            <a:avLst/>
+          </a:prstGeom>
+          <a:noFill/>
+        </p:spPr>
+        <p:txBody>
+          <a:bodyPr wrap="square">
+            <a:spAutoFit/>
+          </a:bodyPr>
+          <a:lstStyle/>
+          <a:p>
+            <a:pPr algn="l">
+              <a:defRPr sz="1400" b="0">
+                <a:solidFill>
+                  <a:srgbClr val="E0E0E0"/>
+                </a:solidFill>
+                <a:latin typeface="Calibri"/>
+              </a:defRPr>
+            </a:pPr>
+            <a:r>
+              <a:t>2. Create start_n8n.py (auto-starts tunnel, sets env vars, launches n8n)</a:t>
+            </a:r>
+          </a:p>
+        </p:txBody>
+      </p:sp>
+      <p:sp>
+        <p:nvSpPr>
+          <p:cNvPr id="21" name="TextBox 20"/>
+          <p:cNvSpPr txBox="1"/>
+          <p:nvPr/>
+        </p:nvSpPr>
+        <p:spPr>
+          <a:xfrm>
+            <a:off x="640080" y="4480559"/>
+            <a:ext cx="10058400" cy="320040"/>
+          </a:xfrm>
+          <a:prstGeom prst="rect">
+            <a:avLst/>
+          </a:prstGeom>
+          <a:noFill/>
+        </p:spPr>
+        <p:txBody>
+          <a:bodyPr wrap="square">
+            <a:spAutoFit/>
+          </a:bodyPr>
+          <a:lstStyle/>
+          <a:p>
+            <a:pPr algn="l">
+              <a:defRPr sz="1400" b="0">
+                <a:solidFill>
+                  <a:srgbClr val="E0E0E0"/>
+                </a:solidFill>
+                <a:latin typeface="Calibri"/>
+              </a:defRPr>
+            </a:pPr>
+            <a:r>
+              <a:t>3. Run: python start_n8n.py</a:t>
+            </a:r>
+          </a:p>
+        </p:txBody>
+      </p:sp>
+      <p:sp>
+        <p:nvSpPr>
+          <p:cNvPr id="22" name="TextBox 21"/>
+          <p:cNvSpPr txBox="1"/>
+          <p:nvPr/>
+        </p:nvSpPr>
+        <p:spPr>
+          <a:xfrm>
+            <a:off x="640080" y="4846320"/>
+            <a:ext cx="10058400" cy="320040"/>
+          </a:xfrm>
+          <a:prstGeom prst="rect">
+            <a:avLst/>
+          </a:prstGeom>
+          <a:noFill/>
+        </p:spPr>
+        <p:txBody>
+          <a:bodyPr wrap="square">
+            <a:spAutoFit/>
+          </a:bodyPr>
+          <a:lstStyle/>
+          <a:p>
+            <a:pPr algn="l">
+              <a:defRPr sz="1400" b="0">
+                <a:solidFill>
+                  <a:srgbClr val="E0E0E0"/>
+                </a:solidFill>
+                <a:latin typeface="Calibri"/>
+              </a:defRPr>
+            </a:pPr>
+            <a:r>
+              <a:t>4. Script auto-extracts URL, sets WEBHOOK_URL/N8N_HOST, starts n8n</a:t>
+            </a:r>
+          </a:p>
+        </p:txBody>
+      </p:sp>
+      <p:sp>
+        <p:nvSpPr>
+          <p:cNvPr id="23" name="Rounded Rectangle 22"/>
           <p:cNvSpPr/>
           <p:nvPr/>
         </p:nvSpPr>
         <p:spPr>
           <a:xfrm>
-            <a:off x="8321040" y="1371600"/>
-            <a:ext cx="3657600" cy="2286000"/>
+            <a:off x="457200" y="5029200"/>
+            <a:ext cx="11247120" cy="1554480"/>
           </a:xfrm>
           <a:prstGeom prst="roundRect">
             <a:avLst/>
@@ -4346,122 +4634,14 @@
       </p:sp>
       <p:sp>
         <p:nvSpPr>
-          <p:cNvPr id="16" name="TextBox 15"/>
-          <p:cNvSpPr txBox="1"/>
-          <p:nvPr/>
-        </p:nvSpPr>
-        <p:spPr>
-          <a:xfrm>
-            <a:off x="8503920" y="1463040"/>
-            <a:ext cx="3291840" cy="365760"/>
-          </a:xfrm>
-          <a:prstGeom prst="rect">
-            <a:avLst/>
-          </a:prstGeom>
-          <a:noFill/>
-        </p:spPr>
-        <p:txBody>
-          <a:bodyPr wrap="square">
-            <a:spAutoFit/>
-          </a:bodyPr>
-          <a:lstStyle/>
-          <a:p>
-            <a:pPr algn="l">
-              <a:defRPr sz="1800" b="1">
-                <a:solidFill>
-                  <a:srgbClr val="A78BFA"/>
-                </a:solidFill>
-                <a:latin typeface="Calibri"/>
-              </a:defRPr>
-            </a:pPr>
-            <a:r>
-              <a:t>Railway/Render</a:t>
-            </a:r>
-          </a:p>
-        </p:txBody>
-      </p:sp>
-      <p:sp>
-        <p:nvSpPr>
-          <p:cNvPr id="17" name="TextBox 16"/>
-          <p:cNvSpPr txBox="1"/>
-          <p:nvPr/>
-        </p:nvSpPr>
-        <p:spPr>
-          <a:xfrm>
-            <a:off x="8503920" y="2011680"/>
-            <a:ext cx="3291840" cy="731520"/>
-          </a:xfrm>
-          <a:prstGeom prst="rect">
-            <a:avLst/>
-          </a:prstGeom>
-          <a:noFill/>
-        </p:spPr>
-        <p:txBody>
-          <a:bodyPr wrap="square">
-            <a:spAutoFit/>
-          </a:bodyPr>
-          <a:lstStyle/>
-          <a:p>
-            <a:pPr algn="l">
-              <a:defRPr sz="1200" b="0">
-                <a:solidFill>
-                  <a:srgbClr val="FBBF24"/>
-                </a:solidFill>
-                <a:latin typeface="Calibri"/>
-              </a:defRPr>
-            </a:pPr>
-            <a:r>
-              <a:t>One-click deploy from GitHub</a:t>
-            </a:r>
-          </a:p>
-        </p:txBody>
-      </p:sp>
-      <p:sp>
-        <p:nvSpPr>
-          <p:cNvPr id="18" name="TextBox 17"/>
-          <p:cNvSpPr txBox="1"/>
-          <p:nvPr/>
-        </p:nvSpPr>
-        <p:spPr>
-          <a:xfrm>
-            <a:off x="8503920" y="2926080"/>
-            <a:ext cx="3291840" cy="365760"/>
-          </a:xfrm>
-          <a:prstGeom prst="rect">
-            <a:avLst/>
-          </a:prstGeom>
-          <a:noFill/>
-        </p:spPr>
-        <p:txBody>
-          <a:bodyPr wrap="square">
-            <a:spAutoFit/>
-          </a:bodyPr>
-          <a:lstStyle/>
-          <a:p>
-            <a:pPr algn="l">
-              <a:defRPr sz="1200" b="0">
-                <a:solidFill>
-                  <a:srgbClr val="34D399"/>
-                </a:solidFill>
-                <a:latin typeface="Calibri"/>
-              </a:defRPr>
-            </a:pPr>
-            <a:r>
-              <a:t>Auto-scaling, simple setup</a:t>
-            </a:r>
-          </a:p>
-        </p:txBody>
-      </p:sp>
-      <p:sp>
-        <p:nvSpPr>
-          <p:cNvPr id="19" name="TextBox 18"/>
-          <p:cNvSpPr txBox="1"/>
-          <p:nvPr/>
-        </p:nvSpPr>
-        <p:spPr>
-          <a:xfrm>
-            <a:off x="457200" y="3931920"/>
-            <a:ext cx="10972800" cy="365760"/>
+          <p:cNvPr id="24" name="TextBox 23"/>
+          <p:cNvSpPr txBox="1"/>
+          <p:nvPr/>
+        </p:nvSpPr>
+        <p:spPr>
+          <a:xfrm>
+            <a:off x="640080" y="5120640"/>
+            <a:ext cx="10058400" cy="365760"/>
           </a:xfrm>
           <a:prstGeom prst="rect">
             <a:avLst/>
@@ -4490,14 +4670,14 @@
       </p:sp>
       <p:sp>
         <p:nvSpPr>
-          <p:cNvPr id="20" name="TextBox 19"/>
-          <p:cNvSpPr txBox="1"/>
-          <p:nvPr/>
-        </p:nvSpPr>
-        <p:spPr>
-          <a:xfrm>
-            <a:off x="640080" y="4389120"/>
-            <a:ext cx="10058400" cy="320040"/>
+          <p:cNvPr id="25" name="TextBox 24"/>
+          <p:cNvSpPr txBox="1"/>
+          <p:nvPr/>
+        </p:nvSpPr>
+        <p:spPr>
+          <a:xfrm>
+            <a:off x="640080" y="5486400"/>
+            <a:ext cx="10058400" cy="274320"/>
           </a:xfrm>
           <a:prstGeom prst="rect">
             <a:avLst/>
@@ -4519,21 +4699,21 @@
               </a:defRPr>
             </a:pPr>
             <a:r>
-              <a:t>Add Google PaLM API credential in n8n Settings &gt; Credentials</a:t>
-            </a:r>
-          </a:p>
-        </p:txBody>
-      </p:sp>
-      <p:sp>
-        <p:nvSpPr>
-          <p:cNvPr id="21" name="TextBox 20"/>
-          <p:cNvSpPr txBox="1"/>
-          <p:nvPr/>
-        </p:nvSpPr>
-        <p:spPr>
-          <a:xfrm>
-            <a:off x="640080" y="4800600"/>
-            <a:ext cx="10058400" cy="320040"/>
+              <a:t>Add Google PaLM API credential</a:t>
+            </a:r>
+          </a:p>
+        </p:txBody>
+      </p:sp>
+      <p:sp>
+        <p:nvSpPr>
+          <p:cNvPr id="26" name="TextBox 25"/>
+          <p:cNvSpPr txBox="1"/>
+          <p:nvPr/>
+        </p:nvSpPr>
+        <p:spPr>
+          <a:xfrm>
+            <a:off x="640080" y="5806440"/>
+            <a:ext cx="10058400" cy="274320"/>
           </a:xfrm>
           <a:prstGeom prst="rect">
             <a:avLst/>
@@ -4555,21 +4735,21 @@
               </a:defRPr>
             </a:pPr>
             <a:r>
-              <a:t>Add Telegram Bot credential (token from @BotFather)</a:t>
-            </a:r>
-          </a:p>
-        </p:txBody>
-      </p:sp>
-      <p:sp>
-        <p:nvSpPr>
-          <p:cNvPr id="22" name="TextBox 21"/>
-          <p:cNvSpPr txBox="1"/>
-          <p:nvPr/>
-        </p:nvSpPr>
-        <p:spPr>
-          <a:xfrm>
-            <a:off x="640080" y="5212080"/>
-            <a:ext cx="10058400" cy="320040"/>
+              <a:t>Add Telegram Bot credential</a:t>
+            </a:r>
+          </a:p>
+        </p:txBody>
+      </p:sp>
+      <p:sp>
+        <p:nvSpPr>
+          <p:cNvPr id="27" name="TextBox 26"/>
+          <p:cNvSpPr txBox="1"/>
+          <p:nvPr/>
+        </p:nvSpPr>
+        <p:spPr>
+          <a:xfrm>
+            <a:off x="640080" y="6126480"/>
+            <a:ext cx="10058400" cy="274320"/>
           </a:xfrm>
           <a:prstGeom prst="rect">
             <a:avLst/>
@@ -4591,21 +4771,21 @@
               </a:defRPr>
             </a:pPr>
             <a:r>
-              <a:t>Set Chat ID in both Telegram nodes (Send resume + Send Cover Letter)</a:t>
-            </a:r>
-          </a:p>
-        </p:txBody>
-      </p:sp>
-      <p:sp>
-        <p:nvSpPr>
-          <p:cNvPr id="23" name="TextBox 22"/>
-          <p:cNvSpPr txBox="1"/>
-          <p:nvPr/>
-        </p:nvSpPr>
-        <p:spPr>
-          <a:xfrm>
-            <a:off x="640080" y="5623560"/>
-            <a:ext cx="10058400" cy="320040"/>
+              <a:t>Set Chat ID in Telegram nodes</a:t>
+            </a:r>
+          </a:p>
+        </p:txBody>
+      </p:sp>
+      <p:sp>
+        <p:nvSpPr>
+          <p:cNvPr id="28" name="TextBox 27"/>
+          <p:cNvSpPr txBox="1"/>
+          <p:nvPr/>
+        </p:nvSpPr>
+        <p:spPr>
+          <a:xfrm>
+            <a:off x="640080" y="6446520"/>
+            <a:ext cx="10058400" cy="274320"/>
           </a:xfrm>
           <a:prstGeom prst="rect">
             <a:avLst/>
@@ -4627,21 +4807,21 @@
               </a:defRPr>
             </a:pPr>
             <a:r>
-              <a:t>Copy Production URL from Form Trigger node</a:t>
-            </a:r>
-          </a:p>
-        </p:txBody>
-      </p:sp>
-      <p:sp>
-        <p:nvSpPr>
-          <p:cNvPr id="24" name="TextBox 23"/>
-          <p:cNvSpPr txBox="1"/>
-          <p:nvPr/>
-        </p:nvSpPr>
-        <p:spPr>
-          <a:xfrm>
-            <a:off x="640080" y="6035040"/>
-            <a:ext cx="10058400" cy="320040"/>
+              <a:t>Copy Production URL from Form Trigger</a:t>
+            </a:r>
+          </a:p>
+        </p:txBody>
+      </p:sp>
+      <p:sp>
+        <p:nvSpPr>
+          <p:cNvPr id="29" name="TextBox 28"/>
+          <p:cNvSpPr txBox="1"/>
+          <p:nvPr/>
+        </p:nvSpPr>
+        <p:spPr>
+          <a:xfrm>
+            <a:off x="640080" y="6766560"/>
+            <a:ext cx="10058400" cy="274320"/>
           </a:xfrm>
           <a:prstGeom prst="rect">
             <a:avLst/>
@@ -4663,7 +4843,7 @@
               </a:defRPr>
             </a:pPr>
             <a:r>
-              <a:t>Toggle workflow from Inactive to Active</a:t>
+              <a:t>Toggle workflow to Active</a:t>
             </a:r>
           </a:p>
         </p:txBody>
@@ -7711,7 +7891,7 @@
               </a:defRPr>
             </a:pPr>
             <a:r>
-              <a:t>AI Resume Optimizer — your resume should work as hard as you do.</a:t>
+              <a:t>AI Resume Optimizer -- your resume should work as hard as you do.</a:t>
             </a:r>
           </a:p>
         </p:txBody>
@@ -7747,7 +7927,7 @@
               </a:defRPr>
             </a:pPr>
             <a:r>
-              <a:t>License: MIT — Free to use, modify, share</a:t>
+              <a:t>License: MIT -- Free to use, modify, share</a:t>
             </a:r>
           </a:p>
         </p:txBody>
@@ -8085,7 +8265,7 @@
               </a:defRPr>
             </a:pPr>
             <a:r>
-              <a:t>What does it do? Everything — fully automatically.</a:t>
+              <a:t>What does it do? Everything -- fully automatically.</a:t>
             </a:r>
           </a:p>
         </p:txBody>
@@ -14001,11 +14181,6 @@
             <a:r>
               <a:t>Auto-routes to best available model. Seamless fallback across providers.</a:t>
             </a:r>
-            <a:br/>
-            <a:br/>
-            <a:r>
-              <a:t>Models listed in config.json. Update node parameters to switch.</a:t>
-            </a:r>
           </a:p>
         </p:txBody>
       </p:sp>
@@ -15459,7 +15634,7 @@
               </a:defRPr>
             </a:pPr>
             <a:r>
-              <a:t>5-paragraph HTML cover letters — Gmail-ready</a:t>
+              <a:t>5-paragraph HTML cover letters -- Gmail-ready</a:t>
             </a:r>
           </a:p>
         </p:txBody>
@@ -16190,7 +16365,7 @@
               </a:defRPr>
             </a:pPr>
             <a:r>
-              <a:t>Real data only — never hallucinate</a:t>
+              <a:t>Real data only -- never hallucinate</a:t>
             </a:r>
           </a:p>
         </p:txBody>
@@ -16615,7 +16790,7 @@
               </a:defRPr>
             </a:pPr>
             <a:r>
-              <a:t>Stage 1 — Resume Intelligence</a:t>
+              <a:t>Stage 1 -- Resume Intelligence</a:t>
             </a:r>
           </a:p>
         </p:txBody>
@@ -16875,7 +17050,7 @@
               </a:defRPr>
             </a:pPr>
             <a:r>
-              <a:t>Stage 2 — JD Intelligence</a:t>
+              <a:t>Stage 2 -- JD Intelligence</a:t>
             </a:r>
           </a:p>
         </p:txBody>
@@ -17135,7 +17310,7 @@
               </a:defRPr>
             </a:pPr>
             <a:r>
-              <a:t>Stage 3 — ATS Generation</a:t>
+              <a:t>Stage 3 -- ATS Generation</a:t>
             </a:r>
           </a:p>
         </p:txBody>

</xml_diff>